<commit_message>
Les parties 1 et 3 sont complètes
</commit_message>
<xml_diff>
--- a/pptx/presentation (Beye+Sene).pptx
+++ b/pptx/presentation (Beye+Sene).pptx
@@ -9246,7 +9246,7 @@
           <a:lstStyle/>
           <a:p>
             <a:r>
-              <a:rPr lang="fr-FR" dirty="0"/>
+              <a:rPr lang="fr-FR" sz="2800" dirty="0"/>
               <a:t>LA PERTE SPATIALE ET SA VALUE-AT-RISK</a:t>
             </a:r>
           </a:p>
@@ -9591,14 +9591,14 @@
           <a:lstStyle/>
           <a:p>
             <a:r>
-              <a:rPr lang="fr-FR" dirty="0"/>
+              <a:rPr lang="fr-FR" sz="2800" dirty="0"/>
               <a:t>ESTIMER LA VAR SPATIALE : UNE MÉTHODE MONTE CARLO</a:t>
             </a:r>
           </a:p>
         </p:txBody>
       </p:sp>
-      <mc:AlternateContent xmlns:mc="http://schemas.openxmlformats.org/markup-compatibility/2006">
-        <mc:Choice xmlns:a14="http://schemas.microsoft.com/office/drawing/2010/main" Requires="a14">
+      <mc:AlternateContent xmlns:mc="http://schemas.openxmlformats.org/markup-compatibility/2006" xmlns:a14="http://schemas.microsoft.com/office/drawing/2010/main">
+        <mc:Choice Requires="a14">
           <p:sp>
             <p:nvSpPr>
               <p:cNvPr id="10" name="intro"/>
@@ -9753,7 +9753,7 @@
             </p:txBody>
           </p:sp>
         </mc:Choice>
-        <mc:Fallback>
+        <mc:Fallback xmlns="">
           <p:sp>
             <p:nvSpPr>
               <p:cNvPr id="10" name="intro"/>
@@ -9835,8 +9835,8 @@
           </a:p>
         </p:txBody>
       </p:sp>
-      <mc:AlternateContent xmlns:mc="http://schemas.openxmlformats.org/markup-compatibility/2006">
-        <mc:Choice xmlns:a14="http://schemas.microsoft.com/office/drawing/2010/main" Requires="a14">
+      <mc:AlternateContent xmlns:mc="http://schemas.openxmlformats.org/markup-compatibility/2006" xmlns:a14="http://schemas.microsoft.com/office/drawing/2010/main">
+        <mc:Choice Requires="a14">
           <p:sp>
             <p:nvSpPr>
               <p:cNvPr id="12" name="step1"/>
@@ -9925,7 +9925,7 @@
             </p:txBody>
           </p:sp>
         </mc:Choice>
-        <mc:Fallback>
+        <mc:Fallback xmlns="">
           <p:sp>
             <p:nvSpPr>
               <p:cNvPr id="12" name="step1"/>
@@ -9964,8 +9964,8 @@
           </p:sp>
         </mc:Fallback>
       </mc:AlternateContent>
-      <mc:AlternateContent xmlns:mc="http://schemas.openxmlformats.org/markup-compatibility/2006">
-        <mc:Choice xmlns:a14="http://schemas.microsoft.com/office/drawing/2010/main" Requires="a14">
+      <mc:AlternateContent xmlns:mc="http://schemas.openxmlformats.org/markup-compatibility/2006" xmlns:a14="http://schemas.microsoft.com/office/drawing/2010/main">
+        <mc:Choice Requires="a14">
           <p:sp>
             <p:nvSpPr>
               <p:cNvPr id="13" name="step2"/>
@@ -10100,7 +10100,7 @@
             </p:txBody>
           </p:sp>
         </mc:Choice>
-        <mc:Fallback>
+        <mc:Fallback xmlns="">
           <p:sp>
             <p:nvSpPr>
               <p:cNvPr id="13" name="step2"/>
@@ -10344,7 +10344,7 @@
           <a:lstStyle/>
           <a:p>
             <a:r>
-              <a:rPr lang="fr-FR" dirty="0"/>
+              <a:rPr lang="fr-FR" sz="2800" dirty="0"/>
               <a:t>DIVERSIFICATION SPATIALE : LE RÉSULTAT ASYMPTOTIQUE</a:t>
             </a:r>
           </a:p>
@@ -10417,8 +10417,8 @@
           </a:prstGeom>
         </p:spPr>
       </p:pic>
-      <mc:AlternateContent xmlns:mc="http://schemas.openxmlformats.org/markup-compatibility/2006">
-        <mc:Choice xmlns:a14="http://schemas.microsoft.com/office/drawing/2010/main" Requires="a14">
+      <mc:AlternateContent xmlns:mc="http://schemas.openxmlformats.org/markup-compatibility/2006" xmlns:a14="http://schemas.microsoft.com/office/drawing/2010/main">
+        <mc:Choice Requires="a14">
           <p:sp>
             <p:nvSpPr>
               <p:cNvPr id="12" name="defs"/>
@@ -10563,7 +10563,7 @@
             </p:txBody>
           </p:sp>
         </mc:Choice>
-        <mc:Fallback>
+        <mc:Fallback xmlns="">
           <p:sp>
             <p:nvSpPr>
               <p:cNvPr id="12" name="defs"/>
@@ -10602,8 +10602,8 @@
           </p:sp>
         </mc:Fallback>
       </mc:AlternateContent>
-      <mc:AlternateContent xmlns:mc="http://schemas.openxmlformats.org/markup-compatibility/2006">
-        <mc:Choice xmlns:a14="http://schemas.microsoft.com/office/drawing/2010/main" Requires="a14">
+      <mc:AlternateContent xmlns:mc="http://schemas.openxmlformats.org/markup-compatibility/2006" xmlns:a14="http://schemas.microsoft.com/office/drawing/2010/main">
+        <mc:Choice Requires="a14">
           <p:sp>
             <p:nvSpPr>
               <p:cNvPr id="13" name="interp"/>
@@ -10825,7 +10825,7 @@
             </p:txBody>
           </p:sp>
         </mc:Choice>
-        <mc:Fallback>
+        <mc:Fallback xmlns="">
           <p:sp>
             <p:nvSpPr>
               <p:cNvPr id="13" name="interp"/>

</xml_diff>